<commit_message>
Regenerate reading deck PDF and PPTX, update slide count to 12
</commit_message>
<xml_diff>
--- a/public/reading-deck/walt-reading-deck.pptx
+++ b/public/reading-deck/walt-reading-deck.pptx
@@ -16,9 +16,10 @@
     <p:sldId id="264" r:id="rId10"/>
     <p:sldId id="265" r:id="rId11"/>
     <p:sldId id="266" r:id="rId12"/>
+    <p:sldId id="267" r:id="rId13"/>
   </p:sldIdLst>
   <p:notesMasterIdLst>
-    <p:notesMasterId r:id="rId13"/>
+    <p:notesMasterId r:id="rId14"/>
   </p:notesMasterIdLst>
   <p:sldSz cx="12192000" cy="6858000"/>
   <p:notesSz cx="6858000" cy="12192000"/>
@@ -712,6 +713,94 @@
             <a:fld id="{F7021451-1387-4CA6-816F-3879F97B5CBC}" type="slidenum">
               <a:rPr lang="en-US"/>
               <a:t>11</a:t>
+            </a:fld>
+            <a:endParaRPr lang="en-US"/>
+          </a:p>
+        </p:txBody>
+      </p:sp>
+    </p:spTree>
+    <p:extLst>
+      <p:ext uri="{BB962C8B-B14F-4D97-AF65-F5344CB8AC3E}">
+        <p14:creationId xmlns:p14="http://schemas.microsoft.com/office/powerpoint/2010/main" val="1024086991"/>
+      </p:ext>
+    </p:extLst>
+  </p:cSld>
+  <p:clrMapOvr>
+    <a:masterClrMapping/>
+  </p:clrMapOvr>
+</p:notes>
+</file>
+
+<file path=ppt/notesSlides/notesSlide12.xml><?xml version="1.0" encoding="utf-8"?>
+<p:notes xmlns:a="http://schemas.openxmlformats.org/drawingml/2006/main" xmlns:r="http://schemas.openxmlformats.org/officeDocument/2006/relationships" xmlns:p="http://schemas.openxmlformats.org/presentationml/2006/main">
+  <p:cSld>
+    <p:spTree>
+      <p:nvGrpSpPr>
+        <p:cNvPr id="1" name=""/>
+        <p:cNvGrpSpPr/>
+        <p:nvPr/>
+      </p:nvGrpSpPr>
+      <p:grpSpPr>
+        <a:xfrm>
+          <a:off x="0" y="0"/>
+          <a:ext cx="0" cy="0"/>
+          <a:chOff x="0" y="0"/>
+          <a:chExt cx="0" cy="0"/>
+        </a:xfrm>
+      </p:grpSpPr>
+      <p:sp>
+        <p:nvSpPr>
+          <p:cNvPr id="2" name="Slide Image Placeholder 1"/>
+          <p:cNvSpPr>
+            <a:spLocks noGrp="1" noRot="1" noChangeAspect="1"/>
+          </p:cNvSpPr>
+          <p:nvPr>
+            <p:ph type="sldImg"/>
+          </p:nvPr>
+        </p:nvSpPr>
+        <p:spPr/>
+      </p:sp>
+      <p:sp>
+        <p:nvSpPr>
+          <p:cNvPr id="3" name="Notes Placeholder 2"/>
+          <p:cNvSpPr>
+            <a:spLocks noGrp="1"/>
+          </p:cNvSpPr>
+          <p:nvPr>
+            <p:ph type="body" idx="1"/>
+          </p:nvPr>
+        </p:nvSpPr>
+        <p:spPr/>
+        <p:txBody>
+          <a:bodyPr/>
+          <a:lstStyle/>
+          <a:p>
+            <a:r>
+              <a:rPr lang="en-US" dirty="0"/>
+              <a:t/>
+            </a:r>
+            <a:endParaRPr lang="en-US" dirty="0"/>
+          </a:p>
+        </p:txBody>
+      </p:sp>
+      <p:sp>
+        <p:nvSpPr>
+          <p:cNvPr id="4" name="Slide Number Placeholder 3"/>
+          <p:cNvSpPr>
+            <a:spLocks noGrp="1"/>
+          </p:cNvSpPr>
+          <p:nvPr>
+            <p:ph type="sldNum" sz="quarter" idx="10"/>
+          </p:nvPr>
+        </p:nvSpPr>
+        <p:spPr/>
+        <p:txBody>
+          <a:bodyPr/>
+          <a:lstStyle/>
+          <a:p>
+            <a:fld id="{F7021451-1387-4CA6-816F-3879F97B5CBC}" type="slidenum">
+              <a:rPr lang="en-US"/>
+              <a:t>12</a:t>
             </a:fld>
             <a:endParaRPr lang="en-US"/>
           </a:p>
@@ -1840,6 +1929,54 @@
 <file path=ppt/slides/slide11.xml><?xml version="1.0" encoding="utf-8"?>
 <p:sld xmlns:a="http://schemas.openxmlformats.org/drawingml/2006/main" xmlns:r="http://schemas.openxmlformats.org/officeDocument/2006/relationships" xmlns:p="http://schemas.openxmlformats.org/presentationml/2006/main">
   <p:cSld name="Slide 11">
+    <p:spTree>
+      <p:nvGrpSpPr>
+        <p:cNvPr id="1" name=""/>
+        <p:cNvGrpSpPr/>
+        <p:nvPr/>
+      </p:nvGrpSpPr>
+      <p:grpSpPr>
+        <a:xfrm>
+          <a:off x="0" y="0"/>
+          <a:ext cx="0" cy="0"/>
+          <a:chOff x="0" y="0"/>
+          <a:chExt cx="0" cy="0"/>
+        </a:xfrm>
+      </p:grpSpPr>
+      <p:pic>
+        <p:nvPicPr>
+          <p:cNvPr id="2" name="Image 0" descr="preencoded.png">    </p:cNvPr>
+          <p:cNvPicPr>
+            <a:picLocks noChangeAspect="1"/>
+          </p:cNvPicPr>
+          <p:nvPr/>
+        </p:nvPicPr>
+        <p:blipFill>
+          <a:blip r:embed="rId1"/>
+          <a:srcRect l="0" r="0" t="0" b="0"/>
+          <a:stretch/>
+        </p:blipFill>
+        <p:spPr>
+          <a:xfrm>
+            <a:off x="0" y="0"/>
+            <a:ext cx="12192000" cy="6858000"/>
+          </a:xfrm>
+          <a:prstGeom prst="rect">
+            <a:avLst/>
+          </a:prstGeom>
+        </p:spPr>
+      </p:pic>
+    </p:spTree>
+  </p:cSld>
+  <p:clrMapOvr>
+    <a:masterClrMapping/>
+  </p:clrMapOvr>
+</p:sld>
+</file>
+
+<file path=ppt/slides/slide12.xml><?xml version="1.0" encoding="utf-8"?>
+<p:sld xmlns:a="http://schemas.openxmlformats.org/drawingml/2006/main" xmlns:r="http://schemas.openxmlformats.org/officeDocument/2006/relationships" xmlns:p="http://schemas.openxmlformats.org/presentationml/2006/main">
+  <p:cSld name="Slide 12">
     <p:spTree>
       <p:nvGrpSpPr>
         <p:cNvPr id="1" name=""/>

</xml_diff>

<commit_message>
Remove Product Deep-Dive slide and regenerate all deck exports
- Delete SlideProduct component and remove from reading deck SLIDES array
- Reading deck: 12 → 11 slides; update export script slideCount
- Regenerate PDF and PPTX for both pitch and reading decks
</commit_message>
<xml_diff>
--- a/public/reading-deck/walt-reading-deck.pptx
+++ b/public/reading-deck/walt-reading-deck.pptx
@@ -16,10 +16,9 @@
     <p:sldId id="264" r:id="rId10"/>
     <p:sldId id="265" r:id="rId11"/>
     <p:sldId id="266" r:id="rId12"/>
-    <p:sldId id="267" r:id="rId13"/>
   </p:sldIdLst>
   <p:notesMasterIdLst>
-    <p:notesMasterId r:id="rId14"/>
+    <p:notesMasterId r:id="rId13"/>
   </p:notesMasterIdLst>
   <p:sldSz cx="12192000" cy="6858000"/>
   <p:notesSz cx="6858000" cy="12192000"/>
@@ -713,94 +712,6 @@
             <a:fld id="{F7021451-1387-4CA6-816F-3879F97B5CBC}" type="slidenum">
               <a:rPr lang="en-US"/>
               <a:t>11</a:t>
-            </a:fld>
-            <a:endParaRPr lang="en-US"/>
-          </a:p>
-        </p:txBody>
-      </p:sp>
-    </p:spTree>
-    <p:extLst>
-      <p:ext uri="{BB962C8B-B14F-4D97-AF65-F5344CB8AC3E}">
-        <p14:creationId xmlns:p14="http://schemas.microsoft.com/office/powerpoint/2010/main" val="1024086991"/>
-      </p:ext>
-    </p:extLst>
-  </p:cSld>
-  <p:clrMapOvr>
-    <a:masterClrMapping/>
-  </p:clrMapOvr>
-</p:notes>
-</file>
-
-<file path=ppt/notesSlides/notesSlide12.xml><?xml version="1.0" encoding="utf-8"?>
-<p:notes xmlns:a="http://schemas.openxmlformats.org/drawingml/2006/main" xmlns:r="http://schemas.openxmlformats.org/officeDocument/2006/relationships" xmlns:p="http://schemas.openxmlformats.org/presentationml/2006/main">
-  <p:cSld>
-    <p:spTree>
-      <p:nvGrpSpPr>
-        <p:cNvPr id="1" name=""/>
-        <p:cNvGrpSpPr/>
-        <p:nvPr/>
-      </p:nvGrpSpPr>
-      <p:grpSpPr>
-        <a:xfrm>
-          <a:off x="0" y="0"/>
-          <a:ext cx="0" cy="0"/>
-          <a:chOff x="0" y="0"/>
-          <a:chExt cx="0" cy="0"/>
-        </a:xfrm>
-      </p:grpSpPr>
-      <p:sp>
-        <p:nvSpPr>
-          <p:cNvPr id="2" name="Slide Image Placeholder 1"/>
-          <p:cNvSpPr>
-            <a:spLocks noGrp="1" noRot="1" noChangeAspect="1"/>
-          </p:cNvSpPr>
-          <p:nvPr>
-            <p:ph type="sldImg"/>
-          </p:nvPr>
-        </p:nvSpPr>
-        <p:spPr/>
-      </p:sp>
-      <p:sp>
-        <p:nvSpPr>
-          <p:cNvPr id="3" name="Notes Placeholder 2"/>
-          <p:cNvSpPr>
-            <a:spLocks noGrp="1"/>
-          </p:cNvSpPr>
-          <p:nvPr>
-            <p:ph type="body" idx="1"/>
-          </p:nvPr>
-        </p:nvSpPr>
-        <p:spPr/>
-        <p:txBody>
-          <a:bodyPr/>
-          <a:lstStyle/>
-          <a:p>
-            <a:r>
-              <a:rPr lang="en-US" dirty="0"/>
-              <a:t/>
-            </a:r>
-            <a:endParaRPr lang="en-US" dirty="0"/>
-          </a:p>
-        </p:txBody>
-      </p:sp>
-      <p:sp>
-        <p:nvSpPr>
-          <p:cNvPr id="4" name="Slide Number Placeholder 3"/>
-          <p:cNvSpPr>
-            <a:spLocks noGrp="1"/>
-          </p:cNvSpPr>
-          <p:nvPr>
-            <p:ph type="sldNum" sz="quarter" idx="10"/>
-          </p:nvPr>
-        </p:nvSpPr>
-        <p:spPr/>
-        <p:txBody>
-          <a:bodyPr/>
-          <a:lstStyle/>
-          <a:p>
-            <a:fld id="{F7021451-1387-4CA6-816F-3879F97B5CBC}" type="slidenum">
-              <a:rPr lang="en-US"/>
-              <a:t>12</a:t>
             </a:fld>
             <a:endParaRPr lang="en-US"/>
           </a:p>
@@ -1929,54 +1840,6 @@
 <file path=ppt/slides/slide11.xml><?xml version="1.0" encoding="utf-8"?>
 <p:sld xmlns:a="http://schemas.openxmlformats.org/drawingml/2006/main" xmlns:r="http://schemas.openxmlformats.org/officeDocument/2006/relationships" xmlns:p="http://schemas.openxmlformats.org/presentationml/2006/main">
   <p:cSld name="Slide 11">
-    <p:spTree>
-      <p:nvGrpSpPr>
-        <p:cNvPr id="1" name=""/>
-        <p:cNvGrpSpPr/>
-        <p:nvPr/>
-      </p:nvGrpSpPr>
-      <p:grpSpPr>
-        <a:xfrm>
-          <a:off x="0" y="0"/>
-          <a:ext cx="0" cy="0"/>
-          <a:chOff x="0" y="0"/>
-          <a:chExt cx="0" cy="0"/>
-        </a:xfrm>
-      </p:grpSpPr>
-      <p:pic>
-        <p:nvPicPr>
-          <p:cNvPr id="2" name="Image 0" descr="preencoded.png">    </p:cNvPr>
-          <p:cNvPicPr>
-            <a:picLocks noChangeAspect="1"/>
-          </p:cNvPicPr>
-          <p:nvPr/>
-        </p:nvPicPr>
-        <p:blipFill>
-          <a:blip r:embed="rId1"/>
-          <a:srcRect l="0" r="0" t="0" b="0"/>
-          <a:stretch/>
-        </p:blipFill>
-        <p:spPr>
-          <a:xfrm>
-            <a:off x="0" y="0"/>
-            <a:ext cx="12192000" cy="6858000"/>
-          </a:xfrm>
-          <a:prstGeom prst="rect">
-            <a:avLst/>
-          </a:prstGeom>
-        </p:spPr>
-      </p:pic>
-    </p:spTree>
-  </p:cSld>
-  <p:clrMapOvr>
-    <a:masterClrMapping/>
-  </p:clrMapOvr>
-</p:sld>
-</file>
-
-<file path=ppt/slides/slide12.xml><?xml version="1.0" encoding="utf-8"?>
-<p:sld xmlns:a="http://schemas.openxmlformats.org/drawingml/2006/main" xmlns:r="http://schemas.openxmlformats.org/officeDocument/2006/relationships" xmlns:p="http://schemas.openxmlformats.org/presentationml/2006/main">
-  <p:cSld name="Slide 12">
     <p:spTree>
       <p:nvGrpSpPr>
         <p:cNvPr id="1" name=""/>

</xml_diff>

<commit_message>
Refactor slide decks into one-file-per-slide architecture (#77)
* Refactor slide decks into one-file-per-slide architecture

Extract all slides from monolithic pitch.js (648 lines) and reading-deck.js
(1,163 lines) into individual component files under components/slides/.

- Shared slides (Title, Closing, Competitors, Ref) extracted once
- Pitch-specific slides: 6 files under slides/pitch/
- Reading-specific slides: 9 files under slides/reading/
- Page files reduced to thin assembly layers (~100 lines each)
- No content changes — pixel-identical rendering
- DeckLayout.js and globals.css untouched
- Export script (PDF/PPTX generation) unaffected

* Remove Product Deep-Dive slide and regenerate all deck exports

- Delete SlideProduct component and remove from reading deck SLIDES array
- Reading deck: 12 → 11 slides; update export script slideCount
- Regenerate PDF and PPTX for both pitch and reading decks
</commit_message>
<xml_diff>
--- a/public/reading-deck/walt-reading-deck.pptx
+++ b/public/reading-deck/walt-reading-deck.pptx
@@ -16,10 +16,9 @@
     <p:sldId id="264" r:id="rId10"/>
     <p:sldId id="265" r:id="rId11"/>
     <p:sldId id="266" r:id="rId12"/>
-    <p:sldId id="267" r:id="rId13"/>
   </p:sldIdLst>
   <p:notesMasterIdLst>
-    <p:notesMasterId r:id="rId14"/>
+    <p:notesMasterId r:id="rId13"/>
   </p:notesMasterIdLst>
   <p:sldSz cx="12192000" cy="6858000"/>
   <p:notesSz cx="6858000" cy="12192000"/>
@@ -713,94 +712,6 @@
             <a:fld id="{F7021451-1387-4CA6-816F-3879F97B5CBC}" type="slidenum">
               <a:rPr lang="en-US"/>
               <a:t>11</a:t>
-            </a:fld>
-            <a:endParaRPr lang="en-US"/>
-          </a:p>
-        </p:txBody>
-      </p:sp>
-    </p:spTree>
-    <p:extLst>
-      <p:ext uri="{BB962C8B-B14F-4D97-AF65-F5344CB8AC3E}">
-        <p14:creationId xmlns:p14="http://schemas.microsoft.com/office/powerpoint/2010/main" val="1024086991"/>
-      </p:ext>
-    </p:extLst>
-  </p:cSld>
-  <p:clrMapOvr>
-    <a:masterClrMapping/>
-  </p:clrMapOvr>
-</p:notes>
-</file>
-
-<file path=ppt/notesSlides/notesSlide12.xml><?xml version="1.0" encoding="utf-8"?>
-<p:notes xmlns:a="http://schemas.openxmlformats.org/drawingml/2006/main" xmlns:r="http://schemas.openxmlformats.org/officeDocument/2006/relationships" xmlns:p="http://schemas.openxmlformats.org/presentationml/2006/main">
-  <p:cSld>
-    <p:spTree>
-      <p:nvGrpSpPr>
-        <p:cNvPr id="1" name=""/>
-        <p:cNvGrpSpPr/>
-        <p:nvPr/>
-      </p:nvGrpSpPr>
-      <p:grpSpPr>
-        <a:xfrm>
-          <a:off x="0" y="0"/>
-          <a:ext cx="0" cy="0"/>
-          <a:chOff x="0" y="0"/>
-          <a:chExt cx="0" cy="0"/>
-        </a:xfrm>
-      </p:grpSpPr>
-      <p:sp>
-        <p:nvSpPr>
-          <p:cNvPr id="2" name="Slide Image Placeholder 1"/>
-          <p:cNvSpPr>
-            <a:spLocks noGrp="1" noRot="1" noChangeAspect="1"/>
-          </p:cNvSpPr>
-          <p:nvPr>
-            <p:ph type="sldImg"/>
-          </p:nvPr>
-        </p:nvSpPr>
-        <p:spPr/>
-      </p:sp>
-      <p:sp>
-        <p:nvSpPr>
-          <p:cNvPr id="3" name="Notes Placeholder 2"/>
-          <p:cNvSpPr>
-            <a:spLocks noGrp="1"/>
-          </p:cNvSpPr>
-          <p:nvPr>
-            <p:ph type="body" idx="1"/>
-          </p:nvPr>
-        </p:nvSpPr>
-        <p:spPr/>
-        <p:txBody>
-          <a:bodyPr/>
-          <a:lstStyle/>
-          <a:p>
-            <a:r>
-              <a:rPr lang="en-US" dirty="0"/>
-              <a:t/>
-            </a:r>
-            <a:endParaRPr lang="en-US" dirty="0"/>
-          </a:p>
-        </p:txBody>
-      </p:sp>
-      <p:sp>
-        <p:nvSpPr>
-          <p:cNvPr id="4" name="Slide Number Placeholder 3"/>
-          <p:cNvSpPr>
-            <a:spLocks noGrp="1"/>
-          </p:cNvSpPr>
-          <p:nvPr>
-            <p:ph type="sldNum" sz="quarter" idx="10"/>
-          </p:nvPr>
-        </p:nvSpPr>
-        <p:spPr/>
-        <p:txBody>
-          <a:bodyPr/>
-          <a:lstStyle/>
-          <a:p>
-            <a:fld id="{F7021451-1387-4CA6-816F-3879F97B5CBC}" type="slidenum">
-              <a:rPr lang="en-US"/>
-              <a:t>12</a:t>
             </a:fld>
             <a:endParaRPr lang="en-US"/>
           </a:p>
@@ -1929,54 +1840,6 @@
 <file path=ppt/slides/slide11.xml><?xml version="1.0" encoding="utf-8"?>
 <p:sld xmlns:a="http://schemas.openxmlformats.org/drawingml/2006/main" xmlns:r="http://schemas.openxmlformats.org/officeDocument/2006/relationships" xmlns:p="http://schemas.openxmlformats.org/presentationml/2006/main">
   <p:cSld name="Slide 11">
-    <p:spTree>
-      <p:nvGrpSpPr>
-        <p:cNvPr id="1" name=""/>
-        <p:cNvGrpSpPr/>
-        <p:nvPr/>
-      </p:nvGrpSpPr>
-      <p:grpSpPr>
-        <a:xfrm>
-          <a:off x="0" y="0"/>
-          <a:ext cx="0" cy="0"/>
-          <a:chOff x="0" y="0"/>
-          <a:chExt cx="0" cy="0"/>
-        </a:xfrm>
-      </p:grpSpPr>
-      <p:pic>
-        <p:nvPicPr>
-          <p:cNvPr id="2" name="Image 0" descr="preencoded.png">    </p:cNvPr>
-          <p:cNvPicPr>
-            <a:picLocks noChangeAspect="1"/>
-          </p:cNvPicPr>
-          <p:nvPr/>
-        </p:nvPicPr>
-        <p:blipFill>
-          <a:blip r:embed="rId1"/>
-          <a:srcRect l="0" r="0" t="0" b="0"/>
-          <a:stretch/>
-        </p:blipFill>
-        <p:spPr>
-          <a:xfrm>
-            <a:off x="0" y="0"/>
-            <a:ext cx="12192000" cy="6858000"/>
-          </a:xfrm>
-          <a:prstGeom prst="rect">
-            <a:avLst/>
-          </a:prstGeom>
-        </p:spPr>
-      </p:pic>
-    </p:spTree>
-  </p:cSld>
-  <p:clrMapOvr>
-    <a:masterClrMapping/>
-  </p:clrMapOvr>
-</p:sld>
-</file>
-
-<file path=ppt/slides/slide12.xml><?xml version="1.0" encoding="utf-8"?>
-<p:sld xmlns:a="http://schemas.openxmlformats.org/drawingml/2006/main" xmlns:r="http://schemas.openxmlformats.org/officeDocument/2006/relationships" xmlns:p="http://schemas.openxmlformats.org/presentationml/2006/main">
-  <p:cSld name="Slide 12">
     <p:spTree>
       <p:nvGrpSpPr>
         <p:cNvPr id="1" name=""/>

</xml_diff>